<commit_message>
updated server and class examples
</commit_message>
<xml_diff>
--- a/Python/Lesson 10 - HTTP and APIs/HTTP and APIs.pptx
+++ b/Python/Lesson 10 - HTTP and APIs/HTTP and APIs.pptx
@@ -223,7 +223,7 @@
           <a:p>
             <a:fld id="{7D2F5B96-EC90-4B10-91AC-E32DA21E81E1}" type="datetimeFigureOut">
               <a:rPr lang="en-US" smtClean="0"/>
-              <a:t>7/10/2026</a:t>
+              <a:t>8/3/2026</a:t>
             </a:fld>
             <a:endParaRPr lang="en-US"/>
           </a:p>
@@ -2550,7 +2550,7 @@
           <a:p>
             <a:fld id="{7A3E0868-4E26-4CDC-8A56-D70E2D8B12FE}" type="datetime3">
               <a:rPr lang="en-US" smtClean="0"/>
-              <a:t>10 July 2026</a:t>
+              <a:t>3 August 2026</a:t>
             </a:fld>
             <a:endParaRPr lang="en-US"/>
           </a:p>
@@ -5129,7 +5129,7 @@
           <a:p>
             <a:fld id="{A7B8021B-6105-4216-96FC-94348F216D0E}" type="datetime3">
               <a:rPr lang="en-US" smtClean="0"/>
-              <a:t>10 July 2026</a:t>
+              <a:t>3 August 2026</a:t>
             </a:fld>
             <a:endParaRPr lang="en-US"/>
           </a:p>
@@ -6850,7 +6850,7 @@
           <a:p>
             <a:fld id="{5D27CFAB-73E6-44A8-B862-B3306344E3F2}" type="datetime3">
               <a:rPr lang="en-US" smtClean="0"/>
-              <a:t>10 July 2026</a:t>
+              <a:t>3 August 2026</a:t>
             </a:fld>
             <a:endParaRPr lang="en-US"/>
           </a:p>
@@ -8664,7 +8664,7 @@
           <a:p>
             <a:fld id="{A9B2E784-A5F5-4301-881B-94AC8DBF9DED}" type="datetime3">
               <a:rPr lang="en-US" smtClean="0"/>
-              <a:t>10 July 2026</a:t>
+              <a:t>3 August 2026</a:t>
             </a:fld>
             <a:endParaRPr lang="en-US"/>
           </a:p>
@@ -8846,7 +8846,7 @@
           <a:p>
             <a:fld id="{18EAB3A5-9E92-4BB9-8F22-9632B4FBEDBA}" type="datetime3">
               <a:rPr lang="en-US" smtClean="0"/>
-              <a:t>10 July 2026</a:t>
+              <a:t>3 August 2026</a:t>
             </a:fld>
             <a:endParaRPr lang="en-US"/>
           </a:p>
@@ -9076,7 +9076,7 @@
           <a:p>
             <a:fld id="{40923810-5FB2-48C9-96CA-1DE2C4773142}" type="datetime3">
               <a:rPr lang="en-US" smtClean="0"/>
-              <a:t>10 July 2026</a:t>
+              <a:t>3 August 2026</a:t>
             </a:fld>
             <a:endParaRPr lang="en-US"/>
           </a:p>
@@ -9375,7 +9375,7 @@
           <a:p>
             <a:fld id="{E50EFF4B-86EB-42FB-93EA-7D8F9CB2466F}" type="datetime3">
               <a:rPr lang="en-US" smtClean="0"/>
-              <a:t>10 July 2026</a:t>
+              <a:t>3 August 2026</a:t>
             </a:fld>
             <a:endParaRPr lang="en-US"/>
           </a:p>
@@ -10005,7 +10005,7 @@
           <a:p>
             <a:fld id="{FB14FC24-E041-45E9-9A72-E5755A86890F}" type="datetime3">
               <a:rPr lang="en-US" smtClean="0"/>
-              <a:t>10 July 2026</a:t>
+              <a:t>3 August 2026</a:t>
             </a:fld>
             <a:endParaRPr lang="en-US"/>
           </a:p>
@@ -10892,7 +10892,7 @@
           <a:p>
             <a:fld id="{98A19125-94A7-4474-858C-FD9C4ABE9DDA}" type="datetime3">
               <a:rPr lang="en-US" smtClean="0"/>
-              <a:t>10 July 2026</a:t>
+              <a:t>3 August 2026</a:t>
             </a:fld>
             <a:endParaRPr lang="en-US"/>
           </a:p>
@@ -12031,7 +12031,7 @@
           <a:p>
             <a:fld id="{3BA0343D-C8D8-43CE-BB79-50DEA219DB07}" type="datetime3">
               <a:rPr lang="en-US" smtClean="0"/>
-              <a:t>10 July 2026</a:t>
+              <a:t>3 August 2026</a:t>
             </a:fld>
             <a:endParaRPr lang="en-US"/>
           </a:p>
@@ -12323,7 +12323,7 @@
           <a:p>
             <a:fld id="{453BD212-0B9F-4987-965F-AC83B2FC354F}" type="datetime3">
               <a:rPr lang="en-US" smtClean="0"/>
-              <a:t>10 July 2026</a:t>
+              <a:t>3 August 2026</a:t>
             </a:fld>
             <a:endParaRPr lang="en-US"/>
           </a:p>
@@ -12568,7 +12568,7 @@
           <a:p>
             <a:fld id="{6DDC931E-8CBE-4A3F-A034-9B6122C6DCDB}" type="datetime3">
               <a:rPr lang="en-US" smtClean="0"/>
-              <a:t>10 July 2026</a:t>
+              <a:t>3 August 2026</a:t>
             </a:fld>
             <a:endParaRPr lang="en-US"/>
           </a:p>
@@ -14346,7 +14346,7 @@
           <a:p>
             <a:fld id="{220AF9C2-5E8A-4308-AE6B-CA9B65007D0E}" type="datetime3">
               <a:rPr lang="en-US" smtClean="0"/>
-              <a:t>10 July 2026</a:t>
+              <a:t>3 August 2026</a:t>
             </a:fld>
             <a:endParaRPr lang="en-US"/>
           </a:p>
@@ -14662,7 +14662,7 @@
           <a:p>
             <a:fld id="{FF31E861-D2AF-431D-860B-DCF67C218052}" type="datetime3">
               <a:rPr lang="en-US" smtClean="0"/>
-              <a:t>10 July 2026</a:t>
+              <a:t>3 August 2026</a:t>
             </a:fld>
             <a:endParaRPr lang="en-US"/>
           </a:p>
@@ -14944,7 +14944,7 @@
           <a:p>
             <a:fld id="{D1DA25B2-AAF1-4C1F-AA38-12D5BFA7D4C8}" type="datetime3">
               <a:rPr lang="en-US" smtClean="0"/>
-              <a:t>10 July 2026</a:t>
+              <a:t>3 August 2026</a:t>
             </a:fld>
             <a:endParaRPr lang="en-US"/>
           </a:p>
@@ -15226,7 +15226,7 @@
           <a:p>
             <a:fld id="{A25C0F39-45D0-48E9-90B3-7FE8FCE561C8}" type="datetime3">
               <a:rPr lang="en-US" smtClean="0"/>
-              <a:t>10 July 2026</a:t>
+              <a:t>3 August 2026</a:t>
             </a:fld>
             <a:endParaRPr lang="en-US"/>
           </a:p>
@@ -15736,7 +15736,7 @@
           <a:p>
             <a:fld id="{9BAF1A3D-92FA-4F24-9781-74AFA516A230}" type="datetime3">
               <a:rPr lang="en-US" smtClean="0"/>
-              <a:t>10 July 2026</a:t>
+              <a:t>3 August 2026</a:t>
             </a:fld>
             <a:endParaRPr lang="en-US"/>
           </a:p>
@@ -15863,7 +15863,7 @@
           <a:p>
             <a:fld id="{5719C672-856D-4617-A693-8FE15749A9B7}" type="datetime3">
               <a:rPr lang="en-US" smtClean="0"/>
-              <a:t>10 July 2026</a:t>
+              <a:t>3 August 2026</a:t>
             </a:fld>
             <a:endParaRPr lang="en-US"/>
           </a:p>
@@ -15998,7 +15998,7 @@
           <a:p>
             <a:fld id="{5F6C764D-A39E-4C03-B161-E0BC66E8883B}" type="datetime3">
               <a:rPr lang="en-US" smtClean="0"/>
-              <a:t>10 July 2026</a:t>
+              <a:t>3 August 2026</a:t>
             </a:fld>
             <a:endParaRPr lang="en-US"/>
           </a:p>
@@ -16240,7 +16240,7 @@
           <a:p>
             <a:fld id="{6E3E33F9-20B7-4995-BE7D-165DBB597850}" type="datetime3">
               <a:rPr lang="en-US" smtClean="0"/>
-              <a:t>10 July 2026</a:t>
+              <a:t>3 August 2026</a:t>
             </a:fld>
             <a:endParaRPr lang="en-US"/>
           </a:p>
@@ -16353,7 +16353,7 @@
           <a:p>
             <a:fld id="{CD41C263-3501-4369-A962-62B6BF915CDE}" type="datetime3">
               <a:rPr lang="en-US" smtClean="0"/>
-              <a:t>10 July 2026</a:t>
+              <a:t>3 August 2026</a:t>
             </a:fld>
             <a:endParaRPr lang="en-US"/>
           </a:p>
@@ -16759,7 +16759,7 @@
           <a:p>
             <a:fld id="{B06F3EBE-B2E8-4992-9F00-9E4B44F057C0}" type="datetime3">
               <a:rPr lang="en-US" smtClean="0"/>
-              <a:t>10 July 2026</a:t>
+              <a:t>3 August 2026</a:t>
             </a:fld>
             <a:endParaRPr lang="en-US"/>
           </a:p>
@@ -16891,7 +16891,7 @@
           <a:p>
             <a:fld id="{D41656AB-D2E1-472E-8B95-0DF5C6E1D623}" type="datetime3">
               <a:rPr lang="en-US" smtClean="0"/>
-              <a:t>10 July 2026</a:t>
+              <a:t>3 August 2026</a:t>
             </a:fld>
             <a:endParaRPr lang="en-US"/>
           </a:p>
@@ -21083,7 +21083,7 @@
           <a:p>
             <a:fld id="{AD3160A9-B1E4-4AE8-B854-46ED2C2068C2}" type="datetimeFigureOut">
               <a:rPr lang="en-US" smtClean="0"/>
-              <a:t>7/10/2026</a:t>
+              <a:t>8/3/2026</a:t>
             </a:fld>
             <a:endParaRPr lang="en-US"/>
           </a:p>
@@ -21495,7 +21495,7 @@
           <a:p>
             <a:fld id="{AD3160A9-B1E4-4AE8-B854-46ED2C2068C2}" type="datetimeFigureOut">
               <a:rPr lang="en-US" smtClean="0"/>
-              <a:t>7/10/2026</a:t>
+              <a:t>8/3/2026</a:t>
             </a:fld>
             <a:endParaRPr lang="en-US"/>
           </a:p>
@@ -21770,7 +21770,7 @@
           <a:p>
             <a:fld id="{AD3160A9-B1E4-4AE8-B854-46ED2C2068C2}" type="datetimeFigureOut">
               <a:rPr lang="en-US" smtClean="0"/>
-              <a:t>7/10/2026</a:t>
+              <a:t>8/3/2026</a:t>
             </a:fld>
             <a:endParaRPr lang="en-US"/>
           </a:p>
@@ -21969,7 +21969,7 @@
           <a:p>
             <a:fld id="{AD622D1A-DF83-41A8-85FF-04D90BF831D3}" type="datetime3">
               <a:rPr lang="en-US" smtClean="0"/>
-              <a:t>10 July 2026</a:t>
+              <a:t>3 August 2026</a:t>
             </a:fld>
             <a:endParaRPr lang="en-US"/>
           </a:p>
@@ -22225,7 +22225,7 @@
           <a:p>
             <a:fld id="{334F72C3-CDF3-44A8-B602-1649B1728485}" type="datetime3">
               <a:rPr lang="en-US" smtClean="0"/>
-              <a:t>10 July 2026</a:t>
+              <a:t>3 August 2026</a:t>
             </a:fld>
             <a:endParaRPr lang="en-US"/>
           </a:p>
@@ -22541,7 +22541,7 @@
           <a:p>
             <a:fld id="{1E0132BA-B5E7-4FFD-AF6C-169169D47D4A}" type="datetime3">
               <a:rPr lang="en-US" smtClean="0"/>
-              <a:t>10 July 2026</a:t>
+              <a:t>3 August 2026</a:t>
             </a:fld>
             <a:endParaRPr lang="en-US"/>
           </a:p>
@@ -23034,7 +23034,7 @@
           <a:p>
             <a:fld id="{81A30091-1C2A-4151-8D3C-D1E47A72615F}" type="datetime3">
               <a:rPr lang="en-US" smtClean="0"/>
-              <a:t>10 July 2026</a:t>
+              <a:t>3 August 2026</a:t>
             </a:fld>
             <a:endParaRPr lang="en-US"/>
           </a:p>
@@ -23695,7 +23695,7 @@
           <a:p>
             <a:fld id="{35D703CE-07B4-4C05-A488-B4566700621F}" type="datetime3">
               <a:rPr lang="en-US" smtClean="0"/>
-              <a:t>10 July 2026</a:t>
+              <a:t>3 August 2026</a:t>
             </a:fld>
             <a:endParaRPr lang="en-US"/>
           </a:p>
@@ -24765,7 +24765,7 @@
           <a:p>
             <a:fld id="{694BD61C-20BA-43AF-A21F-1DAFB3200099}" type="datetime3">
               <a:rPr lang="en-US" smtClean="0"/>
-              <a:t>10 July 2026</a:t>
+              <a:t>3 August 2026</a:t>
             </a:fld>
             <a:endParaRPr lang="en-US"/>
           </a:p>
@@ -25252,7 +25252,7 @@
           <a:p>
             <a:fld id="{CABCB1B0-B6E5-4DD1-BB55-95C076D6C0C8}" type="datetime3">
               <a:rPr lang="en-US" smtClean="0"/>
-              <a:t>10 July 2026</a:t>
+              <a:t>3 August 2026</a:t>
             </a:fld>
             <a:endParaRPr lang="en-US"/>
           </a:p>
@@ -26242,7 +26242,7 @@
           <a:p>
             <a:fld id="{AD622D1A-DF83-41A8-85FF-04D90BF831D3}" type="datetime3">
               <a:rPr lang="en-US" smtClean="0"/>
-              <a:t>10 July 2026</a:t>
+              <a:t>3 August 2026</a:t>
             </a:fld>
             <a:endParaRPr lang="en-US"/>
           </a:p>
@@ -26405,7 +26405,7 @@
           <a:p>
             <a:fld id="{AD622D1A-DF83-41A8-85FF-04D90BF831D3}" type="datetime3">
               <a:rPr lang="en-US" smtClean="0"/>
-              <a:t>10 July 2026</a:t>
+              <a:t>3 August 2026</a:t>
             </a:fld>
             <a:endParaRPr lang="en-US"/>
           </a:p>
@@ -27093,7 +27093,7 @@
           <a:p>
             <a:fld id="{AD622D1A-DF83-41A8-85FF-04D90BF831D3}" type="datetime3">
               <a:rPr lang="en-US" smtClean="0"/>
-              <a:t>10 July 2026</a:t>
+              <a:t>3 August 2026</a:t>
             </a:fld>
             <a:endParaRPr lang="en-US"/>
           </a:p>
@@ -27268,7 +27268,7 @@
           <a:p>
             <a:fld id="{AD622D1A-DF83-41A8-85FF-04D90BF831D3}" type="datetime3">
               <a:rPr lang="en-US" smtClean="0"/>
-              <a:t>10 July 2026</a:t>
+              <a:t>3 August 2026</a:t>
             </a:fld>
             <a:endParaRPr lang="en-US"/>
           </a:p>
@@ -27410,7 +27410,7 @@
           <a:p>
             <a:fld id="{AD622D1A-DF83-41A8-85FF-04D90BF831D3}" type="datetime3">
               <a:rPr lang="en-US" smtClean="0"/>
-              <a:t>10 July 2026</a:t>
+              <a:t>3 August 2026</a:t>
             </a:fld>
             <a:endParaRPr lang="en-US"/>
           </a:p>
@@ -27716,8 +27716,13 @@
           <a:p>
             <a:r>
               <a:rPr lang="en-US" dirty="0"/>
-              <a:t>An API is a set of rules and protocols that allows different software applications to talk to each other and share data seamlessly.</a:t>
-            </a:r>
+              <a:t>An API is a set of rules and protocols </a:t>
+            </a:r>
+            <a:r>
+              <a:rPr lang="en-US"/>
+              <a:t>allowing communication.</a:t>
+            </a:r>
+            <a:endParaRPr lang="en-US" dirty="0"/>
           </a:p>
           <a:p>
             <a:endParaRPr lang="en-US" b="0" dirty="0"/>
@@ -28062,7 +28067,7 @@
             </a:r>
             <a:r>
               <a:rPr lang="en-US" b="0" dirty="0"/>
-              <a:t>: Don’t reinvent the wheel. Instead of building a payment system or mapping tool from scratch, developers can plug in an existing API.</a:t>
+              <a:t>: Don’t reinvent the wheel.</a:t>
             </a:r>
           </a:p>
           <a:p>
@@ -28076,7 +28081,7 @@
             </a:r>
             <a:r>
               <a:rPr lang="en-US" b="0" dirty="0"/>
-              <a:t>: They allow computers to pass information back and forth automatically, eliminating manual data entry.</a:t>
+              <a:t>: Eliminate manual data entry.</a:t>
             </a:r>
           </a:p>
           <a:p>
@@ -28090,7 +28095,7 @@
             </a:r>
             <a:r>
               <a:rPr lang="en-US" b="0" dirty="0"/>
-              <a:t>: APIs only share the specific data requested, keeping the rest of the server's database hidden and secure.</a:t>
+              <a:t>: APIs only share the specific data requested.</a:t>
             </a:r>
           </a:p>
           <a:p>
@@ -28104,7 +28109,7 @@
             </a:r>
             <a:r>
               <a:rPr lang="en-US" b="0" dirty="0"/>
-              <a:t>: They make it easy to connect new features, platforms, and services as a business grows.</a:t>
+              <a:t>: Easy to connect new features, platforms, and services.</a:t>
             </a:r>
           </a:p>
         </p:txBody>
@@ -28824,7 +28829,7 @@
           <a:p>
             <a:fld id="{AD622D1A-DF83-41A8-85FF-04D90BF831D3}" type="datetime3">
               <a:rPr lang="en-US" smtClean="0"/>
-              <a:t>10 July 2026</a:t>
+              <a:t>3 August 2026</a:t>
             </a:fld>
             <a:endParaRPr lang="en-US"/>
           </a:p>
@@ -29045,7 +29050,7 @@
           <a:p>
             <a:fld id="{AD622D1A-DF83-41A8-85FF-04D90BF831D3}" type="datetime3">
               <a:rPr lang="en-US" smtClean="0"/>
-              <a:t>10 July 2026</a:t>
+              <a:t>3 August 2026</a:t>
             </a:fld>
             <a:endParaRPr lang="en-US"/>
           </a:p>
@@ -29425,7 +29430,7 @@
           <a:p>
             <a:fld id="{AD622D1A-DF83-41A8-85FF-04D90BF831D3}" type="datetime3">
               <a:rPr lang="en-US" smtClean="0"/>
-              <a:t>10 July 2026</a:t>
+              <a:t>3 August 2026</a:t>
             </a:fld>
             <a:endParaRPr lang="en-US"/>
           </a:p>
@@ -29947,7 +29952,7 @@
           <a:p>
             <a:fld id="{AD622D1A-DF83-41A8-85FF-04D90BF831D3}" type="datetime3">
               <a:rPr lang="en-US" smtClean="0"/>
-              <a:t>10 July 2026</a:t>
+              <a:t>3 August 2026</a:t>
             </a:fld>
             <a:endParaRPr lang="en-US"/>
           </a:p>
@@ -30096,7 +30101,7 @@
           <a:p>
             <a:fld id="{AD622D1A-DF83-41A8-85FF-04D90BF831D3}" type="datetime3">
               <a:rPr lang="en-US" smtClean="0"/>
-              <a:t>10 July 2026</a:t>
+              <a:t>3 August 2026</a:t>
             </a:fld>
             <a:endParaRPr lang="en-US"/>
           </a:p>
@@ -30213,7 +30218,7 @@
           <a:p>
             <a:fld id="{AD622D1A-DF83-41A8-85FF-04D90BF831D3}" type="datetime3">
               <a:rPr lang="en-US" smtClean="0"/>
-              <a:t>10 July 2026</a:t>
+              <a:t>3 August 2026</a:t>
             </a:fld>
             <a:endParaRPr lang="en-US"/>
           </a:p>
@@ -30414,7 +30419,7 @@
           <a:p>
             <a:fld id="{AD622D1A-DF83-41A8-85FF-04D90BF831D3}" type="datetime3">
               <a:rPr lang="en-US" smtClean="0"/>
-              <a:t>10 July 2026</a:t>
+              <a:t>3 August 2026</a:t>
             </a:fld>
             <a:endParaRPr lang="en-US"/>
           </a:p>
@@ -30592,7 +30597,7 @@
           <a:p>
             <a:fld id="{AD622D1A-DF83-41A8-85FF-04D90BF831D3}" type="datetime3">
               <a:rPr lang="en-US" smtClean="0"/>
-              <a:t>10 July 2026</a:t>
+              <a:t>3 August 2026</a:t>
             </a:fld>
             <a:endParaRPr lang="en-US"/>
           </a:p>
@@ -30894,6 +30899,36 @@
           </a:p>
         </p:txBody>
       </p:sp>
+      <p:pic>
+        <p:nvPicPr>
+          <p:cNvPr id="3" name="Picture 2" descr="What is an HTTP server? · Hyperskill">
+            <a:extLst>
+              <a:ext uri="{FF2B5EF4-FFF2-40B4-BE49-F238E27FC236}">
+                <a16:creationId xmlns:a16="http://schemas.microsoft.com/office/drawing/2014/main" id="{F61D64F0-8179-E8F0-2DA3-EA073A0A4362}"/>
+              </a:ext>
+            </a:extLst>
+          </p:cNvPr>
+          <p:cNvPicPr>
+            <a:picLocks noChangeAspect="1"/>
+          </p:cNvPicPr>
+          <p:nvPr/>
+        </p:nvPicPr>
+        <p:blipFill>
+          <a:blip r:embed="rId3"/>
+          <a:stretch>
+            <a:fillRect/>
+          </a:stretch>
+        </p:blipFill>
+        <p:spPr>
+          <a:xfrm>
+            <a:off x="3667317" y="1706525"/>
+            <a:ext cx="8524683" cy="5151475"/>
+          </a:xfrm>
+          <a:prstGeom prst="rect">
+            <a:avLst/>
+          </a:prstGeom>
+        </p:spPr>
+      </p:pic>
       <p:sp>
         <p:nvSpPr>
           <p:cNvPr id="4" name="Content Placeholder 3">
@@ -30925,7 +30960,14 @@
           <a:p>
             <a:r>
               <a:rPr lang="en-US" dirty="0"/>
-              <a:t>Consists of clients, servers, requests, and responses</a:t>
+              <a:t>Consists of clients, servers, requests, </a:t>
+            </a:r>
+            <a:br>
+              <a:rPr lang="en-US" dirty="0"/>
+            </a:br>
+            <a:r>
+              <a:rPr lang="en-US" dirty="0"/>
+              <a:t>and responses</a:t>
             </a:r>
           </a:p>
           <a:p>
@@ -30952,6 +30994,81 @@
   <p:clrMapOvr>
     <a:masterClrMapping/>
   </p:clrMapOvr>
+  <p:timing>
+    <p:tnLst>
+      <p:par>
+        <p:cTn id="1" dur="indefinite" restart="never" nodeType="tmRoot">
+          <p:childTnLst>
+            <p:seq concurrent="1" nextAc="seek">
+              <p:cTn id="2" dur="indefinite" nodeType="mainSeq">
+                <p:childTnLst>
+                  <p:par>
+                    <p:cTn id="3" fill="hold">
+                      <p:stCondLst>
+                        <p:cond delay="indefinite"/>
+                      </p:stCondLst>
+                      <p:childTnLst>
+                        <p:par>
+                          <p:cTn id="4" fill="hold">
+                            <p:stCondLst>
+                              <p:cond delay="0"/>
+                            </p:stCondLst>
+                            <p:childTnLst>
+                              <p:par>
+                                <p:cTn id="5" presetID="1" presetClass="entr" presetSubtype="0" fill="hold" nodeType="clickEffect">
+                                  <p:stCondLst>
+                                    <p:cond delay="0"/>
+                                  </p:stCondLst>
+                                  <p:childTnLst>
+                                    <p:set>
+                                      <p:cBhvr>
+                                        <p:cTn id="6" dur="1" fill="hold">
+                                          <p:stCondLst>
+                                            <p:cond delay="0"/>
+                                          </p:stCondLst>
+                                        </p:cTn>
+                                        <p:tgtEl>
+                                          <p:spTgt spid="3"/>
+                                        </p:tgtEl>
+                                        <p:attrNameLst>
+                                          <p:attrName>style.visibility</p:attrName>
+                                        </p:attrNameLst>
+                                      </p:cBhvr>
+                                      <p:to>
+                                        <p:strVal val="visible"/>
+                                      </p:to>
+                                    </p:set>
+                                  </p:childTnLst>
+                                </p:cTn>
+                              </p:par>
+                            </p:childTnLst>
+                          </p:cTn>
+                        </p:par>
+                      </p:childTnLst>
+                    </p:cTn>
+                  </p:par>
+                </p:childTnLst>
+              </p:cTn>
+              <p:prevCondLst>
+                <p:cond evt="onPrev" delay="0">
+                  <p:tgtEl>
+                    <p:sldTgt/>
+                  </p:tgtEl>
+                </p:cond>
+              </p:prevCondLst>
+              <p:nextCondLst>
+                <p:cond evt="onNext" delay="0">
+                  <p:tgtEl>
+                    <p:sldTgt/>
+                  </p:tgtEl>
+                </p:cond>
+              </p:nextCondLst>
+            </p:seq>
+          </p:childTnLst>
+        </p:cTn>
+      </p:par>
+    </p:tnLst>
+  </p:timing>
 </p:sld>
 </file>
 
@@ -33169,7 +33286,7 @@
         </p:spPr>
         <p:txBody>
           <a:bodyPr>
-            <a:normAutofit fontScale="77500" lnSpcReduction="20000"/>
+            <a:normAutofit/>
           </a:bodyPr>
           <a:lstStyle/>
           <a:p>
@@ -33179,7 +33296,7 @@
             </a:r>
             <a:r>
               <a:rPr lang="en-US" dirty="0"/>
-              <a:t> A text-based terminal tool that allows you to manually write raw, unencrypted HTTP requests directly to a server's port.</a:t>
+              <a:t> A text-based terminal tool.</a:t>
             </a:r>
           </a:p>
           <a:p>
@@ -33193,7 +33310,7 @@
             </a:r>
             <a:r>
               <a:rPr lang="en-US" dirty="0"/>
-              <a:t> A command-line utility optimized for downloading files, folders, or entire websites from the web with automatic retries.</a:t>
+              <a:t> A command-line utility optimized for downloading files.</a:t>
             </a:r>
           </a:p>
           <a:p>
@@ -33203,7 +33320,7 @@
             </a:r>
             <a:r>
               <a:rPr lang="en-US" dirty="0"/>
-              <a:t> The industry-standard command-line tool for transferring data to or from a server, highly favored for testing and scripting APIs.</a:t>
+              <a:t> The industry-standard command-line tool.</a:t>
             </a:r>
           </a:p>
           <a:p>
@@ -33213,7 +33330,7 @@
             </a:r>
             <a:r>
               <a:rPr lang="en-US" dirty="0"/>
-              <a:t> A user-friendly, graphical application designed for building, testing, organizing, and documenting API requests.</a:t>
+              <a:t> A user-friendly, graphical application.</a:t>
             </a:r>
           </a:p>
           <a:p>
@@ -33223,7 +33340,7 @@
             </a:r>
             <a:r>
               <a:rPr lang="en-US" dirty="0"/>
-              <a:t> A popular, elegant Python library that allows developers to send HTTP/1.1 requests using simple, human-readable code.</a:t>
+              <a:t> A popular, elegant Python library.</a:t>
             </a:r>
           </a:p>
           <a:p>
@@ -33233,7 +33350,7 @@
             </a:r>
             <a:r>
               <a:rPr lang="en-US" dirty="0"/>
-              <a:t> A powerful network packet analyzer that lets you capture and inspect the microscopic, real-time traffic flowing through a network.</a:t>
+              <a:t> A powerful network packet analyzer.</a:t>
             </a:r>
           </a:p>
           <a:p>
@@ -33243,7 +33360,7 @@
             </a:r>
             <a:r>
               <a:rPr lang="en-US" dirty="0"/>
-              <a:t> Web browsers render the user-facing web page, while their built-in Developer Tools (Network Tab) let you inspect the underlying HTTP requests, headers, and payloads driving the page.</a:t>
+              <a:t> built-in Developer Tools (Network Tab).</a:t>
             </a:r>
           </a:p>
           <a:p>

</xml_diff>